<commit_message>
Use consistent blue for all poster chart bars
</commit_message>
<xml_diff>
--- a/Poster.pptx
+++ b/Poster.pptx
@@ -6692,7 +6692,7 @@
             </a:avLst>
           </a:prstGeom>
           <a:solidFill>
-            <a:srgbClr val="173A5B"/>
+            <a:srgbClr val="1A7AE5"/>
           </a:solidFill>
           <a:ln>
             <a:noFill/>
@@ -6880,7 +6880,7 @@
             </a:avLst>
           </a:prstGeom>
           <a:solidFill>
-            <a:srgbClr val="173A5B"/>
+            <a:srgbClr val="1A7AE5"/>
           </a:solidFill>
           <a:ln>
             <a:noFill/>
@@ -7068,7 +7068,7 @@
             </a:avLst>
           </a:prstGeom>
           <a:solidFill>
-            <a:srgbClr val="173A5B"/>
+            <a:srgbClr val="1A7AE5"/>
           </a:solidFill>
           <a:ln>
             <a:noFill/>
@@ -7256,7 +7256,7 @@
             </a:avLst>
           </a:prstGeom>
           <a:solidFill>
-            <a:srgbClr val="173A5B"/>
+            <a:srgbClr val="1A7AE5"/>
           </a:solidFill>
           <a:ln>
             <a:noFill/>
@@ -7444,7 +7444,7 @@
             </a:avLst>
           </a:prstGeom>
           <a:solidFill>
-            <a:srgbClr val="173A5B"/>
+            <a:srgbClr val="1A7AE5"/>
           </a:solidFill>
           <a:ln>
             <a:noFill/>
@@ -8241,7 +8241,7 @@
             </a:avLst>
           </a:prstGeom>
           <a:solidFill>
-            <a:srgbClr val="173A5B"/>
+            <a:srgbClr val="1A7AE5"/>
           </a:solidFill>
           <a:ln>
             <a:noFill/>
@@ -8429,7 +8429,7 @@
             </a:avLst>
           </a:prstGeom>
           <a:solidFill>
-            <a:srgbClr val="173A5B"/>
+            <a:srgbClr val="1A7AE5"/>
           </a:solidFill>
           <a:ln>
             <a:noFill/>
@@ -8617,7 +8617,7 @@
             </a:avLst>
           </a:prstGeom>
           <a:solidFill>
-            <a:srgbClr val="173A5B"/>
+            <a:srgbClr val="1A7AE5"/>
           </a:solidFill>
           <a:ln>
             <a:noFill/>
@@ -8805,7 +8805,7 @@
             </a:avLst>
           </a:prstGeom>
           <a:solidFill>
-            <a:srgbClr val="173A5B"/>
+            <a:srgbClr val="1A7AE5"/>
           </a:solidFill>
           <a:ln>
             <a:noFill/>
@@ -9651,7 +9651,7 @@
             </a:avLst>
           </a:prstGeom>
           <a:solidFill>
-            <a:srgbClr val="173A5B"/>
+            <a:srgbClr val="1A7AE5"/>
           </a:solidFill>
           <a:ln>
             <a:noFill/>
@@ -9839,7 +9839,7 @@
             </a:avLst>
           </a:prstGeom>
           <a:solidFill>
-            <a:srgbClr val="173A5B"/>
+            <a:srgbClr val="1A7AE5"/>
           </a:solidFill>
           <a:ln>
             <a:noFill/>
@@ -10027,7 +10027,7 @@
             </a:avLst>
           </a:prstGeom>
           <a:solidFill>
-            <a:srgbClr val="173A5B"/>
+            <a:srgbClr val="1A7AE5"/>
           </a:solidFill>
           <a:ln>
             <a:noFill/>

</xml_diff>